<commit_message>
Add speaker note to slide 16: expenditure (~$1.74B) behind the $3.5B private return
</commit_message>
<xml_diff>
--- a/paper/ERW_public_private_returns_walkthrough.pptx
+++ b/paper/ERW_public_private_returns_walkthrough.pptx
@@ -1141,7 +1141,7 @@
           <a:p>
             <a:r>
               <a:rPr lang="en-US" dirty="0"/>
-              <a:t/>
+              <a:t>Q: What total expenditure is required to achieve the $3.5 B private return? A: about $1.74 B in delivered basalt cost, summed over the 4.31 Mha private-sufficient envelope (equilibrium maintenance cycle, targeted allocation). So the $3.5 B is gross yield value; net of the $1.74 B ERW cost the private gross margin is about $1.75 B - a benefit-cost ratio of roughly 2:1, before any carbon revenue. Delivered cost here is quarry + grinding + transport + spreading (no MRV, since this is the yield-only case). Source: envelope table, targeted Private row - Area 4.31 Mha, Private $3,496 M, Cost $1,743 M, net-export CDR 7.1 Mt.</a:t>
             </a:r>
             <a:endParaRPr lang="en-US" dirty="0"/>
           </a:p>
@@ -7018,7 +7018,7 @@
       </p:sp>
       <p:sp>
         <p:nvSpPr>
-          <p:cNvPr id="13" name="Text 10"/>
+          <p:cNvPr id="14" name="Text 10"/>
           <p:cNvSpPr/>
           <p:nvPr/>
         </p:nvSpPr>
@@ -7071,7 +7071,7 @@
       </p:sp>
       <p:sp>
         <p:nvSpPr>
-          <p:cNvPr id="14" name="Text 11"/>
+          <p:cNvPr id="15" name="Text 11"/>
           <p:cNvSpPr/>
           <p:nvPr/>
         </p:nvSpPr>

</xml_diff>

<commit_message>
Add delivered-cost map to deck slide 7 (cumulative haul cost from nearest basalt source)
</commit_message>
<xml_diff>
--- a/paper/ERW_public_private_returns_walkthrough.pptx
+++ b/paper/ERW_public_private_returns_walkthrough.pptx
@@ -17016,7 +17016,7 @@
       </p:sp>
       <p:pic>
         <p:nvPicPr>
-          <p:cNvPr id="4" name="Image 0" descr="img/delivered_cost_saving_solar25.png">    </p:cNvPr>
+          <p:cNvPr id="4" name="Image 0" descr="img/delivered_cost_map.png">    </p:cNvPr>
           <p:cNvPicPr>
             <a:picLocks noChangeAspect="1"/>
           </p:cNvPicPr>
@@ -17029,8 +17029,8 @@
         </p:blipFill>
         <p:spPr>
           <a:xfrm>
-            <a:off x="6400800" y="1508760"/>
-            <a:ext cx="5394960" cy="4297680"/>
+            <a:off x="6446520" y="1417320"/>
+            <a:ext cx="5349240" cy="4343400"/>
           </a:xfrm>
           <a:prstGeom prst="rect">
             <a:avLst/>
@@ -17039,7 +17039,49 @@
       </p:pic>
       <p:sp>
         <p:nvSpPr>
-          <p:cNvPr id="5" name="Shape 2"/>
+          <p:cNvPr id="5" name="Text 2"/>
+          <p:cNvSpPr/>
+          <p:nvPr/>
+        </p:nvSpPr>
+        <p:spPr>
+          <a:xfrm>
+            <a:off x="6446520" y="5760720"/>
+            <a:ext cx="5349240" cy="566928"/>
+          </a:xfrm>
+          <a:prstGeom prst="rect">
+            <a:avLst/>
+          </a:prstGeom>
+          <a:noFill/>
+          <a:ln/>
+        </p:spPr>
+        <p:txBody>
+          <a:bodyPr wrap="square" lIns="0" tIns="0" rIns="0" bIns="0" rtlCol="0" anchor="ctr"/>
+          <a:lstStyle/>
+          <a:p>
+            <a:pPr indent="0" marL="0">
+              <a:lnSpc>
+                <a:spcPct val="100000"/>
+              </a:lnSpc>
+              <a:buNone/>
+            </a:pPr>
+            <a:r>
+              <a:rPr lang="en-US" sz="1050" i="1" dirty="0">
+                <a:solidFill>
+                  <a:srgbClr val="5B6B73"/>
+                </a:solidFill>
+                <a:latin typeface="Calibri" pitchFamily="34" charset="0"/>
+                <a:ea typeface="Calibri" pitchFamily="34" charset="-122"/>
+                <a:cs typeface="Calibri" pitchFamily="34" charset="-120"/>
+              </a:rPr>
+              <a:t>Delivered cost surface, cumulative haul from nearest basalt source. Pale = near a source; dark red = at the ~1000 km haul ceiling. About two-thirds of SSA cropland is delivery-cost-bound.</a:t>
+            </a:r>
+            <a:endParaRPr lang="en-US" sz="1050" dirty="0"/>
+          </a:p>
+        </p:txBody>
+      </p:sp>
+      <p:sp>
+        <p:nvSpPr>
+          <p:cNvPr id="6" name="Shape 3"/>
           <p:cNvSpPr/>
           <p:nvPr/>
         </p:nvSpPr>
@@ -17073,7 +17115,7 @@
       </p:sp>
       <p:sp>
         <p:nvSpPr>
-          <p:cNvPr id="6" name="Text 3"/>
+          <p:cNvPr id="7" name="Text 4"/>
           <p:cNvSpPr/>
           <p:nvPr/>
         </p:nvSpPr>
@@ -17133,7 +17175,7 @@
       </p:sp>
       <p:sp>
         <p:nvSpPr>
-          <p:cNvPr id="7" name="Shape 4"/>
+          <p:cNvPr id="8" name="Shape 5"/>
           <p:cNvSpPr/>
           <p:nvPr/>
         </p:nvSpPr>
@@ -17167,7 +17209,7 @@
       </p:sp>
       <p:sp>
         <p:nvSpPr>
-          <p:cNvPr id="8" name="Text 5"/>
+          <p:cNvPr id="9" name="Text 6"/>
           <p:cNvSpPr/>
           <p:nvPr/>
         </p:nvSpPr>
@@ -17227,7 +17269,7 @@
       </p:sp>
       <p:sp>
         <p:nvSpPr>
-          <p:cNvPr id="9" name="Shape 6"/>
+          <p:cNvPr id="10" name="Shape 7"/>
           <p:cNvSpPr/>
           <p:nvPr/>
         </p:nvSpPr>
@@ -17261,7 +17303,7 @@
       </p:sp>
       <p:sp>
         <p:nvSpPr>
-          <p:cNvPr id="10" name="Text 7"/>
+          <p:cNvPr id="11" name="Text 8"/>
           <p:cNvSpPr/>
           <p:nvPr/>
         </p:nvSpPr>
@@ -17321,7 +17363,7 @@
       </p:sp>
       <p:sp>
         <p:nvSpPr>
-          <p:cNvPr id="11" name="Shape 8"/>
+          <p:cNvPr id="12" name="Shape 9"/>
           <p:cNvSpPr/>
           <p:nvPr/>
         </p:nvSpPr>
@@ -17355,7 +17397,7 @@
       </p:sp>
       <p:sp>
         <p:nvSpPr>
-          <p:cNvPr id="12" name="Text 9"/>
+          <p:cNvPr id="13" name="Text 10"/>
           <p:cNvSpPr/>
           <p:nvPr/>
         </p:nvSpPr>
@@ -17415,7 +17457,7 @@
       </p:sp>
       <p:sp>
         <p:nvSpPr>
-          <p:cNvPr id="13" name="Text 10"/>
+          <p:cNvPr id="14" name="Text 11"/>
           <p:cNvSpPr/>
           <p:nvPr/>
         </p:nvSpPr>
@@ -17468,7 +17510,7 @@
       </p:sp>
       <p:sp>
         <p:nvSpPr>
-          <p:cNvPr id="14" name="Text 11"/>
+          <p:cNvPr id="15" name="Text 12"/>
           <p:cNvSpPr/>
           <p:nvPr/>
         </p:nvSpPr>

</xml_diff>

<commit_message>
Walkthrough deck: PDF companion regenerated; document metadata set
- paper/ and docs/ copies of ERW_Public_Private_Returns_Walkthrough.pdf now
  render the rebuilt 2026-09 deck (LibreOffice headless export) instead of the
  superseded 2026-07 version; the docs/ pptx copy is synced too
- generator sets proper core properties (title, Gebrekidan & Chamberlin as
  authors) instead of python-pptx template defaults, and uses ASCII hyphens in
  formulas so minus signs survive font substitution in PDF export
- docs/ HTML walkthrough and speaker script remain the superseded 2026-07
  companions (flagged in deck-update-checklist.md)
</commit_message>
<xml_diff>
--- a/paper/ERW_public_private_returns_walkthrough.pptx
+++ b/paper/ERW_public_private_returns_walkthrough.pptx
@@ -3512,7 +3512,7 @@
                 </a:solidFill>
                 <a:latin typeface="Avenir Next"/>
               </a:rPr>
-              <a:t>durable CDR = max( gross − F·S , 0 )</a:t>
+              <a:t>durable CDR = max( gross - F·S , 0 )</a:t>
             </a:r>
           </a:p>
           <a:p>
@@ -6261,7 +6261,7 @@
                 </a:solidFill>
                 <a:latin typeface="Avenir Next"/>
               </a:rPr>
-              <a:t>R_agro − C &gt; 0</a:t>
+              <a:t>R_agro - C &gt; 0</a:t>
             </a:r>
           </a:p>
         </p:txBody>
@@ -6387,7 +6387,7 @@
                 </a:solidFill>
                 <a:latin typeface="Avenir Next"/>
               </a:rPr>
-              <a:t>R_CDR − C &gt; 0</a:t>
+              <a:t>R_CDR - C &gt; 0</a:t>
             </a:r>
           </a:p>
         </p:txBody>
@@ -9015,7 +9015,7 @@
                 </a:solidFill>
                 <a:latin typeface="Avenir Next"/>
               </a:rPr>
-              <a:t>MAC = delivered cost per tonne of rock ÷ durable CDR per tonne. The public envelope is exactly the land where MAC &lt; (p − m).</a:t>
+              <a:t>MAC = delivered cost per tonne of rock ÷ durable CDR per tonne. The public envelope is exactly the land where MAC &lt; (p - m).</a:t>
             </a:r>
           </a:p>
           <a:p>
@@ -9372,7 +9372,7 @@
                 </a:solidFill>
                 <a:latin typeface="Avenir Next"/>
               </a:rPr>
-              <a:t>1 · The price–cost ratio (p − m)/c</a:t>
+              <a:t>1 · The price–cost ratio (p - m)/c</a:t>
             </a:r>
           </a:p>
           <a:p>
@@ -12605,7 +12605,7 @@
                 </a:solidFill>
                 <a:latin typeface="Avenir Next"/>
               </a:rPr>
-              <a:t>  −  C</a:t>
+              <a:t>  -  C</a:t>
             </a:r>
           </a:p>
           <a:p>
@@ -12621,7 +12621,7 @@
                 </a:solidFill>
                 <a:latin typeface="Avenir Next"/>
               </a:rPr>
-              <a:t>gross margin = private agronomic return + public carbon return − full delivered cost</a:t>
+              <a:t>gross margin = private agronomic return + public carbon return - full delivered cost</a:t>
             </a:r>
           </a:p>
         </p:txBody>
@@ -14532,7 +14532,7 @@
                 </a:solidFill>
                 <a:latin typeface="Avenir Next"/>
               </a:rPr>
-              <a:t>Electrified / solar-assisted haulage cuts the variable transport term: −25% transport widens the private envelope 4.31 → 5.12 Mha, the public one only 1.95 → 2.07.</a:t>
+              <a:t>Electrified / solar-assisted haulage cuts the variable transport term: -25% transport widens the private envelope 4.31 → 5.12 Mha, the public one only 1.95 → 2.07.</a:t>
             </a:r>
           </a:p>
         </p:txBody>
@@ -16243,7 +16243,7 @@
                 </a:solidFill>
                 <a:latin typeface="Avenir Next"/>
               </a:rPr>
-              <a:t>  =  durable CDR × ( p − m )</a:t>
+              <a:t>  =  durable CDR × ( p - m )</a:t>
             </a:r>
           </a:p>
           <a:p>
@@ -16316,7 +16316,7 @@
                 </a:solidFill>
                 <a:latin typeface="Avenir Next"/>
               </a:rPr>
-              <a:t> — a conservative floor: 2024–25 durable-CDR transactions cluster at $250–450/tCO₂ (CDR.fyi). Price, MRV and delivered cost move the public envelope only through the single ratio (p − m)/c.</a:t>
+              <a:t> — a conservative floor: 2024–25 durable-CDR transactions cluster at $250–450/tCO₂ (CDR.fyi). Price, MRV and delivered cost move the public envelope only through the single ratio (p - m)/c.</a:t>
             </a:r>
           </a:p>
           <a:p>

</xml_diff>